<commit_message>
Trabalho 03 - Data Lake
</commit_message>
<xml_diff>
--- a/encceja-knn/Apresentacao_ENCCEJA_KNN.pptx
+++ b/encceja-knn/Apresentacao_ENCCEJA_KNN.pptx
@@ -627,32 +627,15 @@
           <a:bodyPr/>
           <a:lstStyle/>
           <a:p>
-            <a:r>
-              <a:rPr lang="pt-BR" sz="1200" b="0" kern="1200" dirty="0">
-                <a:solidFill>
-                  <a:schemeClr val="tx1"/>
-                </a:solidFill>
-                <a:effectLst/>
-                <a:latin typeface="+mn-lt"/>
-                <a:ea typeface="+mn-ea"/>
-                <a:cs typeface="+mn-cs"/>
-              </a:rPr>
-              <a:t>Olá. Este trabalho apresenta um Sistema de Apoio à Decisão para um cursinho preparatório</a:t>
-            </a:r>
-          </a:p>
-          <a:p>
-            <a:r>
-              <a:rPr lang="pt-BR" sz="1200" b="0" kern="1200" dirty="0">
-                <a:solidFill>
-                  <a:schemeClr val="tx1"/>
-                </a:solidFill>
-                <a:effectLst/>
-                <a:latin typeface="+mn-lt"/>
-                <a:ea typeface="+mn-ea"/>
-                <a:cs typeface="+mn-cs"/>
-              </a:rPr>
-              <a:t>do ENCCEJA. </a:t>
-            </a:r>
+            <a:endParaRPr lang="pt-BR" sz="1200" b="0" kern="1200" dirty="0">
+              <a:solidFill>
+                <a:schemeClr val="tx1"/>
+              </a:solidFill>
+              <a:effectLst/>
+              <a:latin typeface="+mn-lt"/>
+              <a:ea typeface="+mn-ea"/>
+              <a:cs typeface="+mn-cs"/>
+            </a:endParaRPr>
           </a:p>
         </p:txBody>
       </p:sp>
@@ -820,88 +803,6 @@
           <a:bodyPr/>
           <a:lstStyle/>
           <a:p>
-            <a:r>
-              <a:rPr lang="pt-BR" sz="1200" b="0" kern="1200" dirty="0">
-                <a:solidFill>
-                  <a:schemeClr val="tx1"/>
-                </a:solidFill>
-                <a:effectLst/>
-                <a:latin typeface="+mn-lt"/>
-                <a:ea typeface="+mn-ea"/>
-                <a:cs typeface="+mn-cs"/>
-              </a:rPr>
-              <a:t>O problema é concreto: quando um aluno se matricula, o gestor conhece só o</a:t>
-            </a:r>
-          </a:p>
-          <a:p>
-            <a:r>
-              <a:rPr lang="pt-BR" sz="1200" b="0" kern="1200" dirty="0">
-                <a:solidFill>
-                  <a:schemeClr val="tx1"/>
-                </a:solidFill>
-                <a:effectLst/>
-                <a:latin typeface="+mn-lt"/>
-                <a:ea typeface="+mn-ea"/>
-                <a:cs typeface="+mn-cs"/>
-              </a:rPr>
-              <a:t>perfil socioeconômico dele — idade, sexo, região, se trabalha, renda, escolaridade — mas</a:t>
-            </a:r>
-          </a:p>
-          <a:p>
-            <a:r>
-              <a:rPr lang="pt-BR" sz="1200" b="1" kern="1200" dirty="0">
-                <a:solidFill>
-                  <a:schemeClr val="tx1"/>
-                </a:solidFill>
-                <a:effectLst/>
-                <a:latin typeface="+mn-lt"/>
-                <a:ea typeface="+mn-ea"/>
-                <a:cs typeface="+mn-cs"/>
-              </a:rPr>
-              <a:t>**não conhece o desempenho**</a:t>
-            </a:r>
-            <a:r>
-              <a:rPr lang="pt-BR" sz="1200" b="0" kern="1200" dirty="0">
-                <a:solidFill>
-                  <a:schemeClr val="tx1"/>
-                </a:solidFill>
-                <a:effectLst/>
-                <a:latin typeface="+mn-lt"/>
-                <a:ea typeface="+mn-ea"/>
-                <a:cs typeface="+mn-cs"/>
-              </a:rPr>
-              <a:t>. Mesmo assim, precisa decidir nível de acompanhamento,</a:t>
-            </a:r>
-          </a:p>
-          <a:p>
-            <a:r>
-              <a:rPr lang="pt-BR" sz="1200" b="0" kern="1200" dirty="0">
-                <a:solidFill>
-                  <a:schemeClr val="tx1"/>
-                </a:solidFill>
-                <a:effectLst/>
-                <a:latin typeface="+mn-lt"/>
-                <a:ea typeface="+mn-ea"/>
-                <a:cs typeface="+mn-cs"/>
-              </a:rPr>
-              <a:t>necessidade de reforço e alocação de turmas e professores. A pergunta central é: *dá para</a:t>
-            </a:r>
-          </a:p>
-          <a:p>
-            <a:r>
-              <a:rPr lang="pt-BR" sz="1200" b="0" kern="1200" dirty="0">
-                <a:solidFill>
-                  <a:schemeClr val="tx1"/>
-                </a:solidFill>
-                <a:effectLst/>
-                <a:latin typeface="+mn-lt"/>
-                <a:ea typeface="+mn-ea"/>
-                <a:cs typeface="+mn-cs"/>
-              </a:rPr>
-              <a:t>apoiar essa decisão usando o histórico de candidatos parecidos?*</a:t>
-            </a:r>
-          </a:p>
-          <a:p>
             <a:endParaRPr lang="en-US" dirty="0"/>
           </a:p>
         </p:txBody>
@@ -986,194 +887,15 @@
           <a:bodyPr/>
           <a:lstStyle/>
           <a:p>
-            <a:r>
-              <a:rPr lang="pt-BR" sz="1200" b="0" kern="1200" dirty="0">
-                <a:solidFill>
-                  <a:schemeClr val="tx1"/>
-                </a:solidFill>
-                <a:effectLst/>
-                <a:latin typeface="+mn-lt"/>
-                <a:ea typeface="+mn-ea"/>
-                <a:cs typeface="+mn-cs"/>
-              </a:rPr>
-              <a:t>A resposta foi construir um sistema com o algoritmo </a:t>
-            </a:r>
-            <a:r>
-              <a:rPr lang="pt-BR" sz="1200" b="1" kern="1200" dirty="0">
-                <a:solidFill>
-                  <a:schemeClr val="tx1"/>
-                </a:solidFill>
-                <a:effectLst/>
-                <a:latin typeface="+mn-lt"/>
-                <a:ea typeface="+mn-ea"/>
-                <a:cs typeface="+mn-cs"/>
-              </a:rPr>
-              <a:t>**K-</a:t>
-            </a:r>
-            <a:r>
-              <a:rPr lang="pt-BR" sz="1200" b="1" kern="1200" dirty="0" err="1">
-                <a:solidFill>
-                  <a:schemeClr val="tx1"/>
-                </a:solidFill>
-                <a:effectLst/>
-                <a:latin typeface="+mn-lt"/>
-                <a:ea typeface="+mn-ea"/>
-                <a:cs typeface="+mn-cs"/>
-              </a:rPr>
-              <a:t>Nearest</a:t>
-            </a:r>
-            <a:r>
-              <a:rPr lang="pt-BR" sz="1200" b="1" kern="1200" dirty="0">
-                <a:solidFill>
-                  <a:schemeClr val="tx1"/>
-                </a:solidFill>
-                <a:effectLst/>
-                <a:latin typeface="+mn-lt"/>
-                <a:ea typeface="+mn-ea"/>
-                <a:cs typeface="+mn-cs"/>
-              </a:rPr>
-              <a:t> </a:t>
-            </a:r>
-            <a:r>
-              <a:rPr lang="pt-BR" sz="1200" b="1" kern="1200" dirty="0" err="1">
-                <a:solidFill>
-                  <a:schemeClr val="tx1"/>
-                </a:solidFill>
-                <a:effectLst/>
-                <a:latin typeface="+mn-lt"/>
-                <a:ea typeface="+mn-ea"/>
-                <a:cs typeface="+mn-cs"/>
-              </a:rPr>
-              <a:t>Neighbors</a:t>
-            </a:r>
-            <a:r>
-              <a:rPr lang="pt-BR" sz="1200" b="1" kern="1200" dirty="0">
-                <a:solidFill>
-                  <a:schemeClr val="tx1"/>
-                </a:solidFill>
-                <a:effectLst/>
-                <a:latin typeface="+mn-lt"/>
-                <a:ea typeface="+mn-ea"/>
-                <a:cs typeface="+mn-cs"/>
-              </a:rPr>
-              <a:t>**</a:t>
-            </a:r>
-            <a:r>
-              <a:rPr lang="pt-BR" sz="1200" b="0" kern="1200" dirty="0">
-                <a:solidFill>
-                  <a:schemeClr val="tx1"/>
-                </a:solidFill>
-                <a:effectLst/>
-                <a:latin typeface="+mn-lt"/>
-                <a:ea typeface="+mn-ea"/>
-                <a:cs typeface="+mn-cs"/>
-              </a:rPr>
-              <a:t>, o K-NN.</a:t>
-            </a:r>
-          </a:p>
-          <a:p>
-            <a:r>
-              <a:rPr lang="pt-BR" sz="1200" b="0" kern="1200" dirty="0">
-                <a:solidFill>
-                  <a:schemeClr val="tx1"/>
-                </a:solidFill>
-                <a:effectLst/>
-                <a:latin typeface="+mn-lt"/>
-                <a:ea typeface="+mn-ea"/>
-                <a:cs typeface="+mn-cs"/>
-              </a:rPr>
-              <a:t>A ideia é simples e poderosa: para um candidato novo, o sistema procura no histórico do</a:t>
-            </a:r>
-          </a:p>
-          <a:p>
-            <a:r>
-              <a:rPr lang="pt-BR" sz="1200" b="0" kern="1200" dirty="0">
-                <a:solidFill>
-                  <a:schemeClr val="tx1"/>
-                </a:solidFill>
-                <a:effectLst/>
-                <a:latin typeface="+mn-lt"/>
-                <a:ea typeface="+mn-ea"/>
-                <a:cs typeface="+mn-cs"/>
-              </a:rPr>
-              <a:t>ENCCEJA os participantes mais </a:t>
-            </a:r>
-            <a:r>
-              <a:rPr lang="pt-BR" sz="1200" b="1" kern="1200" dirty="0">
-                <a:solidFill>
-                  <a:schemeClr val="tx1"/>
-                </a:solidFill>
-                <a:effectLst/>
-                <a:latin typeface="+mn-lt"/>
-                <a:ea typeface="+mn-ea"/>
-                <a:cs typeface="+mn-cs"/>
-              </a:rPr>
-              <a:t>**semelhantes**</a:t>
-            </a:r>
-            <a:r>
-              <a:rPr lang="pt-BR" sz="1200" b="0" kern="1200" dirty="0">
-                <a:solidFill>
-                  <a:schemeClr val="tx1"/>
-                </a:solidFill>
-                <a:effectLst/>
-                <a:latin typeface="+mn-lt"/>
-                <a:ea typeface="+mn-ea"/>
-                <a:cs typeface="+mn-cs"/>
-              </a:rPr>
-              <a:t> em perfil e usa o desempenho deles para</a:t>
-            </a:r>
-          </a:p>
-          <a:p>
-            <a:r>
-              <a:rPr lang="pt-BR" sz="1200" b="0" kern="1200" dirty="0">
-                <a:solidFill>
-                  <a:schemeClr val="tx1"/>
-                </a:solidFill>
-                <a:effectLst/>
-                <a:latin typeface="+mn-lt"/>
-                <a:ea typeface="+mn-ea"/>
-                <a:cs typeface="+mn-cs"/>
-              </a:rPr>
-              <a:t>estimar as notas esperadas e o risco de reprovação do candidato. O foco não é o algoritmo</a:t>
-            </a:r>
-          </a:p>
-          <a:p>
-            <a:r>
-              <a:rPr lang="pt-BR" sz="1200" b="0" kern="1200" dirty="0">
-                <a:solidFill>
-                  <a:schemeClr val="tx1"/>
-                </a:solidFill>
-                <a:effectLst/>
-                <a:latin typeface="+mn-lt"/>
-                <a:ea typeface="+mn-ea"/>
-                <a:cs typeface="+mn-cs"/>
-              </a:rPr>
-              <a:t>em si, e sim </a:t>
-            </a:r>
-            <a:r>
-              <a:rPr lang="pt-BR" sz="1200" b="1" kern="1200" dirty="0">
-                <a:solidFill>
-                  <a:schemeClr val="tx1"/>
-                </a:solidFill>
-                <a:effectLst/>
-                <a:latin typeface="+mn-lt"/>
-                <a:ea typeface="+mn-ea"/>
-                <a:cs typeface="+mn-cs"/>
-              </a:rPr>
-              <a:t>**apoiar a decisão gerencial**</a:t>
-            </a:r>
-            <a:r>
-              <a:rPr lang="pt-BR" sz="1200" b="0" kern="1200" dirty="0">
-                <a:solidFill>
-                  <a:schemeClr val="tx1"/>
-                </a:solidFill>
-                <a:effectLst/>
-                <a:latin typeface="+mn-lt"/>
-                <a:ea typeface="+mn-ea"/>
-                <a:cs typeface="+mn-cs"/>
-              </a:rPr>
-              <a:t>.</a:t>
-            </a:r>
+            <a:endParaRPr lang="pt-BR" sz="1200" b="0" kern="1200" dirty="0">
+              <a:solidFill>
+                <a:schemeClr val="tx1"/>
+              </a:solidFill>
+              <a:effectLst/>
+              <a:latin typeface="+mn-lt"/>
+              <a:ea typeface="+mn-ea"/>
+              <a:cs typeface="+mn-cs"/>
+            </a:endParaRPr>
           </a:p>
         </p:txBody>
       </p:sp>
@@ -1257,74 +979,15 @@
           <a:bodyPr/>
           <a:lstStyle/>
           <a:p>
-            <a:r>
-              <a:rPr lang="pt-BR" sz="1200" b="0" kern="1200" dirty="0">
-                <a:solidFill>
-                  <a:schemeClr val="tx1"/>
-                </a:solidFill>
-                <a:effectLst/>
-                <a:latin typeface="+mn-lt"/>
-                <a:ea typeface="+mn-ea"/>
-                <a:cs typeface="+mn-cs"/>
-              </a:rPr>
-              <a:t>Usei os microdados oficiais do ENCCEJA 2024, do INEP — o arquivo nacional regular, com</a:t>
-            </a:r>
-          </a:p>
-          <a:p>
-            <a:r>
-              <a:rPr lang="pt-BR" sz="1200" b="0" kern="1200" dirty="0">
-                <a:solidFill>
-                  <a:schemeClr val="tx1"/>
-                </a:solidFill>
-                <a:effectLst/>
-                <a:latin typeface="+mn-lt"/>
-                <a:ea typeface="+mn-ea"/>
-                <a:cs typeface="+mn-cs"/>
-              </a:rPr>
-              <a:t>117 variáveis e cerca de 835 mil registros. Cada linha reúne, num só arquivo, os dados de</a:t>
-            </a:r>
-          </a:p>
-          <a:p>
-            <a:r>
-              <a:rPr lang="pt-BR" sz="1200" b="0" kern="1200" dirty="0">
-                <a:solidFill>
-                  <a:schemeClr val="tx1"/>
-                </a:solidFill>
-                <a:effectLst/>
-                <a:latin typeface="+mn-lt"/>
-                <a:ea typeface="+mn-ea"/>
-                <a:cs typeface="+mn-cs"/>
-              </a:rPr>
-              <a:t>inscrição, as notas e a aprovação por área, e o questionário socioeconômico de 75 perguntas.</a:t>
-            </a:r>
-          </a:p>
-          <a:p>
-            <a:r>
-              <a:rPr lang="pt-BR" sz="1200" b="0" kern="1200" dirty="0">
-                <a:solidFill>
-                  <a:schemeClr val="tx1"/>
-                </a:solidFill>
-                <a:effectLst/>
-                <a:latin typeface="+mn-lt"/>
-                <a:ea typeface="+mn-ea"/>
-                <a:cs typeface="+mn-cs"/>
-              </a:rPr>
-              <a:t>As variáveis usadas no perfil foram exatamente as pedidas no enunciado: certificação,</a:t>
-            </a:r>
-          </a:p>
-          <a:p>
-            <a:r>
-              <a:rPr lang="pt-BR" sz="1200" b="0" kern="1200" dirty="0">
-                <a:solidFill>
-                  <a:schemeClr val="tx1"/>
-                </a:solidFill>
-                <a:effectLst/>
-                <a:latin typeface="+mn-lt"/>
-                <a:ea typeface="+mn-ea"/>
-                <a:cs typeface="+mn-cs"/>
-              </a:rPr>
-              <a:t>faixa etária, sexo, UF, situação de trabalho, renda familiar e escolaridade anterior.</a:t>
-            </a:r>
+            <a:endParaRPr lang="pt-BR" sz="1200" b="0" kern="1200" dirty="0">
+              <a:solidFill>
+                <a:schemeClr val="tx1"/>
+              </a:solidFill>
+              <a:effectLst/>
+              <a:latin typeface="+mn-lt"/>
+              <a:ea typeface="+mn-ea"/>
+              <a:cs typeface="+mn-cs"/>
+            </a:endParaRPr>
           </a:p>
         </p:txBody>
       </p:sp>
@@ -1408,30 +1071,6 @@
           <a:bodyPr/>
           <a:lstStyle/>
           <a:p>
-            <a:r>
-              <a:rPr lang="pt-BR" sz="1200" b="0" kern="1200" dirty="0">
-                <a:solidFill>
-                  <a:schemeClr val="tx1"/>
-                </a:solidFill>
-                <a:effectLst/>
-                <a:latin typeface="+mn-lt"/>
-                <a:ea typeface="+mn-ea"/>
-                <a:cs typeface="+mn-cs"/>
-              </a:rPr>
-              <a:t>Os dados brutos precisaram de higienização. Primeiro, mantive só quem </a:t>
-            </a:r>
-            <a:r>
-              <a:rPr lang="pt-BR" sz="1200" b="1" kern="1200" dirty="0">
-                <a:solidFill>
-                  <a:schemeClr val="tx1"/>
-                </a:solidFill>
-                <a:effectLst/>
-                <a:latin typeface="+mn-lt"/>
-                <a:ea typeface="+mn-ea"/>
-                <a:cs typeface="+mn-cs"/>
-              </a:rPr>
-              <a:t>**esteve presente**</a:t>
-            </a:r>
             <a:endParaRPr lang="pt-BR" sz="1200" b="0" kern="1200" dirty="0">
               <a:solidFill>
                 <a:schemeClr val="tx1"/>
@@ -1441,214 +1080,6 @@
               <a:ea typeface="+mn-ea"/>
               <a:cs typeface="+mn-cs"/>
             </a:endParaRPr>
-          </a:p>
-          <a:p>
-            <a:r>
-              <a:rPr lang="pt-BR" sz="1200" b="0" kern="1200" dirty="0">
-                <a:solidFill>
-                  <a:schemeClr val="tx1"/>
-                </a:solidFill>
-                <a:effectLst/>
-                <a:latin typeface="+mn-lt"/>
-                <a:ea typeface="+mn-ea"/>
-                <a:cs typeface="+mn-cs"/>
-              </a:rPr>
-              <a:t>nas quatro provas — quem faltou não tem nota. Depois, descartei notas inválidas e registros</a:t>
-            </a:r>
-          </a:p>
-          <a:p>
-            <a:r>
-              <a:rPr lang="pt-BR" sz="1200" b="0" kern="1200" dirty="0">
-                <a:solidFill>
-                  <a:schemeClr val="tx1"/>
-                </a:solidFill>
-                <a:effectLst/>
-                <a:latin typeface="+mn-lt"/>
-                <a:ea typeface="+mn-ea"/>
-                <a:cs typeface="+mn-cs"/>
-              </a:rPr>
-              <a:t>sem perfil completo. Recodifiquei as variáveis: "trabalha" virou Sim/Não; renda e</a:t>
-            </a:r>
-          </a:p>
-          <a:p>
-            <a:r>
-              <a:rPr lang="pt-BR" sz="1200" b="0" kern="1200" dirty="0">
-                <a:solidFill>
-                  <a:schemeClr val="tx1"/>
-                </a:solidFill>
-                <a:effectLst/>
-                <a:latin typeface="+mn-lt"/>
-                <a:ea typeface="+mn-ea"/>
-                <a:cs typeface="+mn-cs"/>
-              </a:rPr>
-              <a:t>escolaridade viraram </a:t>
-            </a:r>
-            <a:r>
-              <a:rPr lang="pt-BR" sz="1200" b="1" kern="1200" dirty="0">
-                <a:solidFill>
-                  <a:schemeClr val="tx1"/>
-                </a:solidFill>
-                <a:effectLst/>
-                <a:latin typeface="+mn-lt"/>
-                <a:ea typeface="+mn-ea"/>
-                <a:cs typeface="+mn-cs"/>
-              </a:rPr>
-              <a:t>**escalas ordinais**</a:t>
-            </a:r>
-            <a:r>
-              <a:rPr lang="pt-BR" sz="1200" b="0" kern="1200" dirty="0">
-                <a:solidFill>
-                  <a:schemeClr val="tx1"/>
-                </a:solidFill>
-                <a:effectLst/>
-                <a:latin typeface="+mn-lt"/>
-                <a:ea typeface="+mn-ea"/>
-                <a:cs typeface="+mn-cs"/>
-              </a:rPr>
-              <a:t>; a categoria "não sei" da renda foi imputada com</a:t>
-            </a:r>
-          </a:p>
-          <a:p>
-            <a:r>
-              <a:rPr lang="pt-BR" sz="1200" b="0" kern="1200" dirty="0">
-                <a:solidFill>
-                  <a:schemeClr val="tx1"/>
-                </a:solidFill>
-                <a:effectLst/>
-                <a:latin typeface="+mn-lt"/>
-                <a:ea typeface="+mn-ea"/>
-                <a:cs typeface="+mn-cs"/>
-              </a:rPr>
-              <a:t>a mediana para não perder registros. Sobraram </a:t>
-            </a:r>
-            <a:r>
-              <a:rPr lang="pt-BR" sz="1200" b="1" kern="1200" dirty="0">
-                <a:solidFill>
-                  <a:schemeClr val="tx1"/>
-                </a:solidFill>
-                <a:effectLst/>
-                <a:latin typeface="+mn-lt"/>
-                <a:ea typeface="+mn-ea"/>
-                <a:cs typeface="+mn-cs"/>
-              </a:rPr>
-              <a:t>**133 mil participantes**</a:t>
-            </a:r>
-            <a:r>
-              <a:rPr lang="pt-BR" sz="1200" b="0" kern="1200" dirty="0">
-                <a:solidFill>
-                  <a:schemeClr val="tx1"/>
-                </a:solidFill>
-                <a:effectLst/>
-                <a:latin typeface="+mn-lt"/>
-                <a:ea typeface="+mn-ea"/>
-                <a:cs typeface="+mn-cs"/>
-              </a:rPr>
-              <a:t> consistentes.</a:t>
-            </a:r>
-          </a:p>
-          <a:p>
-            <a:r>
-              <a:rPr lang="pt-BR" sz="1200" b="0" kern="1200" dirty="0">
-                <a:solidFill>
-                  <a:schemeClr val="tx1"/>
-                </a:solidFill>
-                <a:effectLst/>
-                <a:latin typeface="+mn-lt"/>
-                <a:ea typeface="+mn-ea"/>
-                <a:cs typeface="+mn-cs"/>
-              </a:rPr>
-              <a:t>Por fim, a </a:t>
-            </a:r>
-            <a:r>
-              <a:rPr lang="pt-BR" sz="1200" b="1" kern="1200" dirty="0">
-                <a:solidFill>
-                  <a:schemeClr val="tx1"/>
-                </a:solidFill>
-                <a:effectLst/>
-                <a:latin typeface="+mn-lt"/>
-                <a:ea typeface="+mn-ea"/>
-                <a:cs typeface="+mn-cs"/>
-              </a:rPr>
-              <a:t>**normalização**</a:t>
-            </a:r>
-            <a:r>
-              <a:rPr lang="pt-BR" sz="1200" b="0" kern="1200" dirty="0">
-                <a:solidFill>
-                  <a:schemeClr val="tx1"/>
-                </a:solidFill>
-                <a:effectLst/>
-                <a:latin typeface="+mn-lt"/>
-                <a:ea typeface="+mn-ea"/>
-                <a:cs typeface="+mn-cs"/>
-              </a:rPr>
-              <a:t>: como o K-NN usa distância, todas as variáveis foram colocadas</a:t>
-            </a:r>
-          </a:p>
-          <a:p>
-            <a:r>
-              <a:rPr lang="pt-BR" sz="1200" b="0" kern="1200" dirty="0">
-                <a:solidFill>
-                  <a:schemeClr val="tx1"/>
-                </a:solidFill>
-                <a:effectLst/>
-                <a:latin typeface="+mn-lt"/>
-                <a:ea typeface="+mn-ea"/>
-                <a:cs typeface="+mn-cs"/>
-              </a:rPr>
-              <a:t>na mesma escala, de 0 a 1, para nenhuma dominar o cálculo. A região recebeu um peso</a:t>
-            </a:r>
-          </a:p>
-          <a:p>
-            <a:r>
-              <a:rPr lang="pt-BR" sz="1200" b="0" kern="1200" dirty="0">
-                <a:solidFill>
-                  <a:schemeClr val="tx1"/>
-                </a:solidFill>
-                <a:effectLst/>
-                <a:latin typeface="+mn-lt"/>
-                <a:ea typeface="+mn-ea"/>
-                <a:cs typeface="+mn-cs"/>
-              </a:rPr>
-              <a:t>calibrado para isso, e o nível de certificação virou um </a:t>
-            </a:r>
-            <a:r>
-              <a:rPr lang="pt-BR" sz="1200" b="1" kern="1200" dirty="0">
-                <a:solidFill>
-                  <a:schemeClr val="tx1"/>
-                </a:solidFill>
-                <a:effectLst/>
-                <a:latin typeface="+mn-lt"/>
-                <a:ea typeface="+mn-ea"/>
-                <a:cs typeface="+mn-cs"/>
-              </a:rPr>
-              <a:t>**filtro**</a:t>
-            </a:r>
-            <a:r>
-              <a:rPr lang="pt-BR" sz="1200" b="0" kern="1200" dirty="0">
-                <a:solidFill>
-                  <a:schemeClr val="tx1"/>
-                </a:solidFill>
-                <a:effectLst/>
-                <a:latin typeface="+mn-lt"/>
-                <a:ea typeface="+mn-ea"/>
-                <a:cs typeface="+mn-cs"/>
-              </a:rPr>
-              <a:t> — um candidato do Médio</a:t>
-            </a:r>
-          </a:p>
-          <a:p>
-            <a:r>
-              <a:rPr lang="pt-BR" sz="1200" b="0" kern="1200" dirty="0">
-                <a:solidFill>
-                  <a:schemeClr val="tx1"/>
-                </a:solidFill>
-                <a:effectLst/>
-                <a:latin typeface="+mn-lt"/>
-                <a:ea typeface="+mn-ea"/>
-                <a:cs typeface="+mn-cs"/>
-              </a:rPr>
-              <a:t>só é comparado a participantes do Médio, porque as provas são diferentes.</a:t>
-            </a:r>
           </a:p>
         </p:txBody>
       </p:sp>
@@ -1732,226 +1163,6 @@
           <a:bodyPr/>
           <a:lstStyle/>
           <a:p>
-            <a:r>
-              <a:rPr lang="pt-BR" sz="1200" b="0" kern="1200" dirty="0">
-                <a:solidFill>
-                  <a:schemeClr val="tx1"/>
-                </a:solidFill>
-                <a:effectLst/>
-                <a:latin typeface="+mn-lt"/>
-                <a:ea typeface="+mn-ea"/>
-                <a:cs typeface="+mn-cs"/>
-              </a:rPr>
-              <a:t>O K-NN foi implementado de forma transparente, em Python com </a:t>
-            </a:r>
-            <a:r>
-              <a:rPr lang="pt-BR" sz="1200" b="0" kern="1200" dirty="0" err="1">
-                <a:solidFill>
-                  <a:schemeClr val="tx1"/>
-                </a:solidFill>
-                <a:effectLst/>
-                <a:latin typeface="+mn-lt"/>
-                <a:ea typeface="+mn-ea"/>
-                <a:cs typeface="+mn-cs"/>
-              </a:rPr>
-              <a:t>NumPy</a:t>
-            </a:r>
-            <a:r>
-              <a:rPr lang="pt-BR" sz="1200" b="0" kern="1200" dirty="0">
-                <a:solidFill>
-                  <a:schemeClr val="tx1"/>
-                </a:solidFill>
-                <a:effectLst/>
-                <a:latin typeface="+mn-lt"/>
-                <a:ea typeface="+mn-ea"/>
-                <a:cs typeface="+mn-cs"/>
-              </a:rPr>
-              <a:t>, em três passos.</a:t>
-            </a:r>
-          </a:p>
-          <a:p>
-            <a:r>
-              <a:rPr lang="pt-BR" sz="1200" b="1" kern="1200" dirty="0">
-                <a:solidFill>
-                  <a:schemeClr val="tx1"/>
-                </a:solidFill>
-                <a:effectLst/>
-                <a:latin typeface="+mn-lt"/>
-                <a:ea typeface="+mn-ea"/>
-                <a:cs typeface="+mn-cs"/>
-              </a:rPr>
-              <a:t>**Um:**</a:t>
-            </a:r>
-            <a:r>
-              <a:rPr lang="pt-BR" sz="1200" b="0" kern="1200" dirty="0">
-                <a:solidFill>
-                  <a:schemeClr val="tx1"/>
-                </a:solidFill>
-                <a:effectLst/>
-                <a:latin typeface="+mn-lt"/>
-                <a:ea typeface="+mn-ea"/>
-                <a:cs typeface="+mn-cs"/>
-              </a:rPr>
-              <a:t> o perfil do candidato é convertido no mesmo vetor normalizado da base.</a:t>
-            </a:r>
-          </a:p>
-          <a:p>
-            <a:r>
-              <a:rPr lang="pt-BR" sz="1200" b="1" kern="1200" dirty="0">
-                <a:solidFill>
-                  <a:schemeClr val="tx1"/>
-                </a:solidFill>
-                <a:effectLst/>
-                <a:latin typeface="+mn-lt"/>
-                <a:ea typeface="+mn-ea"/>
-                <a:cs typeface="+mn-cs"/>
-              </a:rPr>
-              <a:t>**Dois:**</a:t>
-            </a:r>
-            <a:r>
-              <a:rPr lang="pt-BR" sz="1200" b="0" kern="1200" dirty="0">
-                <a:solidFill>
-                  <a:schemeClr val="tx1"/>
-                </a:solidFill>
-                <a:effectLst/>
-                <a:latin typeface="+mn-lt"/>
-                <a:ea typeface="+mn-ea"/>
-                <a:cs typeface="+mn-cs"/>
-              </a:rPr>
-              <a:t> calculo a distância euclidiana dele para todos os participantes do mesmo nível.</a:t>
-            </a:r>
-          </a:p>
-          <a:p>
-            <a:r>
-              <a:rPr lang="pt-BR" sz="1200" b="1" kern="1200" dirty="0">
-                <a:solidFill>
-                  <a:schemeClr val="tx1"/>
-                </a:solidFill>
-                <a:effectLst/>
-                <a:latin typeface="+mn-lt"/>
-                <a:ea typeface="+mn-ea"/>
-                <a:cs typeface="+mn-cs"/>
-              </a:rPr>
-              <a:t>**Três:**</a:t>
-            </a:r>
-            <a:r>
-              <a:rPr lang="pt-BR" sz="1200" b="0" kern="1200" dirty="0">
-                <a:solidFill>
-                  <a:schemeClr val="tx1"/>
-                </a:solidFill>
-                <a:effectLst/>
-                <a:latin typeface="+mn-lt"/>
-                <a:ea typeface="+mn-ea"/>
-                <a:cs typeface="+mn-cs"/>
-              </a:rPr>
-              <a:t> seleciono os `k` de menor distância — os vizinhos mais parecidos.</a:t>
-            </a:r>
-          </a:p>
-          <a:p>
-            <a:r>
-              <a:rPr lang="pt-BR" sz="1200" b="0" kern="1200" dirty="0">
-                <a:solidFill>
-                  <a:schemeClr val="tx1"/>
-                </a:solidFill>
-                <a:effectLst/>
-                <a:latin typeface="+mn-lt"/>
-                <a:ea typeface="+mn-ea"/>
-                <a:cs typeface="+mn-cs"/>
-              </a:rPr>
-              <a:t>Com esses vizinhos, faço duas coisas. A </a:t>
-            </a:r>
-            <a:r>
-              <a:rPr lang="pt-BR" sz="1200" b="1" kern="1200" dirty="0">
-                <a:solidFill>
-                  <a:schemeClr val="tx1"/>
-                </a:solidFill>
-                <a:effectLst/>
-                <a:latin typeface="+mn-lt"/>
-                <a:ea typeface="+mn-ea"/>
-                <a:cs typeface="+mn-cs"/>
-              </a:rPr>
-              <a:t>**nota esperada**</a:t>
-            </a:r>
-            <a:r>
-              <a:rPr lang="pt-BR" sz="1200" b="0" kern="1200" dirty="0">
-                <a:solidFill>
-                  <a:schemeClr val="tx1"/>
-                </a:solidFill>
-                <a:effectLst/>
-                <a:latin typeface="+mn-lt"/>
-                <a:ea typeface="+mn-ea"/>
-                <a:cs typeface="+mn-cs"/>
-              </a:rPr>
-              <a:t> de cada área é a média das notas</a:t>
-            </a:r>
-          </a:p>
-          <a:p>
-            <a:r>
-              <a:rPr lang="pt-BR" sz="1200" b="0" kern="1200" dirty="0">
-                <a:solidFill>
-                  <a:schemeClr val="tx1"/>
-                </a:solidFill>
-                <a:effectLst/>
-                <a:latin typeface="+mn-lt"/>
-                <a:ea typeface="+mn-ea"/>
-                <a:cs typeface="+mn-cs"/>
-              </a:rPr>
-              <a:t>dos vizinhos — isso é regressão. E o </a:t>
-            </a:r>
-            <a:r>
-              <a:rPr lang="pt-BR" sz="1200" b="1" kern="1200" dirty="0">
-                <a:solidFill>
-                  <a:schemeClr val="tx1"/>
-                </a:solidFill>
-                <a:effectLst/>
-                <a:latin typeface="+mn-lt"/>
-                <a:ea typeface="+mn-ea"/>
-                <a:cs typeface="+mn-cs"/>
-              </a:rPr>
-              <a:t>**risco de reprovação**</a:t>
-            </a:r>
-            <a:r>
-              <a:rPr lang="pt-BR" sz="1200" b="0" kern="1200" dirty="0">
-                <a:solidFill>
-                  <a:schemeClr val="tx1"/>
-                </a:solidFill>
-                <a:effectLst/>
-                <a:latin typeface="+mn-lt"/>
-                <a:ea typeface="+mn-ea"/>
-                <a:cs typeface="+mn-cs"/>
-              </a:rPr>
-              <a:t> é a proporção de vizinhos que</a:t>
-            </a:r>
-          </a:p>
-          <a:p>
-            <a:r>
-              <a:rPr lang="pt-BR" sz="1200" b="0" kern="1200" dirty="0">
-                <a:solidFill>
-                  <a:schemeClr val="tx1"/>
-                </a:solidFill>
-                <a:effectLst/>
-                <a:latin typeface="+mn-lt"/>
-                <a:ea typeface="+mn-ea"/>
-                <a:cs typeface="+mn-cs"/>
-              </a:rPr>
-              <a:t>foram aprovados — isso é classificação. Se a maioria dos semelhantes reprovou, o candidato</a:t>
-            </a:r>
-          </a:p>
-          <a:p>
-            <a:r>
-              <a:rPr lang="pt-BR" sz="1200" b="0" kern="1200" dirty="0">
-                <a:solidFill>
-                  <a:schemeClr val="tx1"/>
-                </a:solidFill>
-                <a:effectLst/>
-                <a:latin typeface="+mn-lt"/>
-                <a:ea typeface="+mn-ea"/>
-                <a:cs typeface="+mn-cs"/>
-              </a:rPr>
-              <a:t>herda esse alto risco.</a:t>
-            </a:r>
-          </a:p>
-          <a:p>
             <a:endParaRPr lang="en-US" dirty="0"/>
           </a:p>
         </p:txBody>
@@ -2036,334 +1247,6 @@
           <a:bodyPr/>
           <a:lstStyle/>
           <a:p>
-            <a:r>
-              <a:rPr lang="pt-BR" sz="1200" b="0" i="1" kern="1200" dirty="0">
-                <a:solidFill>
-                  <a:schemeClr val="tx1"/>
-                </a:solidFill>
-                <a:effectLst/>
-                <a:latin typeface="+mn-lt"/>
-                <a:ea typeface="+mn-ea"/>
-                <a:cs typeface="+mn-cs"/>
-              </a:rPr>
-              <a:t>*(Mostrar a tela do `app_gui.py` em execução.)*</a:t>
-            </a:r>
-            <a:endParaRPr lang="pt-BR" sz="1200" b="0" kern="1200" dirty="0">
-              <a:solidFill>
-                <a:schemeClr val="tx1"/>
-              </a:solidFill>
-              <a:effectLst/>
-              <a:latin typeface="+mn-lt"/>
-              <a:ea typeface="+mn-ea"/>
-              <a:cs typeface="+mn-cs"/>
-            </a:endParaRPr>
-          </a:p>
-          <a:p>
-            <a:r>
-              <a:rPr lang="pt-BR" sz="1200" b="0" kern="1200" dirty="0">
-                <a:solidFill>
-                  <a:schemeClr val="tx1"/>
-                </a:solidFill>
-                <a:effectLst/>
-                <a:latin typeface="+mn-lt"/>
-                <a:ea typeface="+mn-ea"/>
-                <a:cs typeface="+mn-cs"/>
-              </a:rPr>
-              <a:t>Esta é a interface. O gestor preenche o perfil do candidato e clica em "Analisar".</a:t>
-            </a:r>
-          </a:p>
-          <a:p>
-            <a:r>
-              <a:rPr lang="pt-BR" sz="1200" b="0" kern="1200" dirty="0">
-                <a:solidFill>
-                  <a:schemeClr val="tx1"/>
-                </a:solidFill>
-                <a:effectLst/>
-                <a:latin typeface="+mn-lt"/>
-                <a:ea typeface="+mn-ea"/>
-                <a:cs typeface="+mn-cs"/>
-              </a:rPr>
-              <a:t>O sistema retorna, por área, a </a:t>
-            </a:r>
-            <a:r>
-              <a:rPr lang="pt-BR" sz="1200" b="1" kern="1200" dirty="0">
-                <a:solidFill>
-                  <a:schemeClr val="tx1"/>
-                </a:solidFill>
-                <a:effectLst/>
-                <a:latin typeface="+mn-lt"/>
-                <a:ea typeface="+mn-ea"/>
-                <a:cs typeface="+mn-cs"/>
-              </a:rPr>
-              <a:t>**nota esperada**</a:t>
-            </a:r>
-            <a:r>
-              <a:rPr lang="pt-BR" sz="1200" b="0" kern="1200" dirty="0">
-                <a:solidFill>
-                  <a:schemeClr val="tx1"/>
-                </a:solidFill>
-                <a:effectLst/>
-                <a:latin typeface="+mn-lt"/>
-                <a:ea typeface="+mn-ea"/>
-                <a:cs typeface="+mn-cs"/>
-              </a:rPr>
-              <a:t>, a </a:t>
-            </a:r>
-            <a:r>
-              <a:rPr lang="pt-BR" sz="1200" b="1" kern="1200" dirty="0">
-                <a:solidFill>
-                  <a:schemeClr val="tx1"/>
-                </a:solidFill>
-                <a:effectLst/>
-                <a:latin typeface="+mn-lt"/>
-                <a:ea typeface="+mn-ea"/>
-                <a:cs typeface="+mn-cs"/>
-              </a:rPr>
-              <a:t>**faixa de notas dos vizinhos**</a:t>
-            </a:r>
-            <a:r>
-              <a:rPr lang="pt-BR" sz="1200" b="0" kern="1200" dirty="0">
-                <a:solidFill>
-                  <a:schemeClr val="tx1"/>
-                </a:solidFill>
-                <a:effectLst/>
-                <a:latin typeface="+mn-lt"/>
-                <a:ea typeface="+mn-ea"/>
-                <a:cs typeface="+mn-cs"/>
-              </a:rPr>
-              <a:t>, a</a:t>
-            </a:r>
-          </a:p>
-          <a:p>
-            <a:r>
-              <a:rPr lang="pt-BR" sz="1200" b="1" kern="1200" dirty="0">
-                <a:solidFill>
-                  <a:schemeClr val="tx1"/>
-                </a:solidFill>
-                <a:effectLst/>
-                <a:latin typeface="+mn-lt"/>
-                <a:ea typeface="+mn-ea"/>
-                <a:cs typeface="+mn-cs"/>
-              </a:rPr>
-              <a:t>**comparação com a média do nível**</a:t>
-            </a:r>
-            <a:r>
-              <a:rPr lang="pt-BR" sz="1200" b="0" kern="1200" dirty="0">
-                <a:solidFill>
-                  <a:schemeClr val="tx1"/>
-                </a:solidFill>
-                <a:effectLst/>
-                <a:latin typeface="+mn-lt"/>
-                <a:ea typeface="+mn-ea"/>
-                <a:cs typeface="+mn-cs"/>
-              </a:rPr>
-              <a:t> e o </a:t>
-            </a:r>
-            <a:r>
-              <a:rPr lang="pt-BR" sz="1200" b="1" kern="1200" dirty="0">
-                <a:solidFill>
-                  <a:schemeClr val="tx1"/>
-                </a:solidFill>
-                <a:effectLst/>
-                <a:latin typeface="+mn-lt"/>
-                <a:ea typeface="+mn-ea"/>
-                <a:cs typeface="+mn-cs"/>
-              </a:rPr>
-              <a:t>**percentual de vizinhos aprovados**</a:t>
-            </a:r>
-            <a:r>
-              <a:rPr lang="pt-BR" sz="1200" b="0" kern="1200" dirty="0">
-                <a:solidFill>
-                  <a:schemeClr val="tx1"/>
-                </a:solidFill>
-                <a:effectLst/>
-                <a:latin typeface="+mn-lt"/>
-                <a:ea typeface="+mn-ea"/>
-                <a:cs typeface="+mn-cs"/>
-              </a:rPr>
-              <a:t>.</a:t>
-            </a:r>
-          </a:p>
-          <a:p>
-            <a:r>
-              <a:rPr lang="pt-BR" sz="1200" b="0" kern="1200" dirty="0">
-                <a:solidFill>
-                  <a:schemeClr val="tx1"/>
-                </a:solidFill>
-                <a:effectLst/>
-                <a:latin typeface="+mn-lt"/>
-                <a:ea typeface="+mn-ea"/>
-                <a:cs typeface="+mn-cs"/>
-              </a:rPr>
-              <a:t>No topo aparece o </a:t>
-            </a:r>
-            <a:r>
-              <a:rPr lang="pt-BR" sz="1200" b="1" kern="1200" dirty="0">
-                <a:solidFill>
-                  <a:schemeClr val="tx1"/>
-                </a:solidFill>
-                <a:effectLst/>
-                <a:latin typeface="+mn-lt"/>
-                <a:ea typeface="+mn-ea"/>
-                <a:cs typeface="+mn-cs"/>
-              </a:rPr>
-              <a:t>**risco**</a:t>
-            </a:r>
-            <a:r>
-              <a:rPr lang="pt-BR" sz="1200" b="0" kern="1200" dirty="0">
-                <a:solidFill>
-                  <a:schemeClr val="tx1"/>
-                </a:solidFill>
-                <a:effectLst/>
-                <a:latin typeface="+mn-lt"/>
-                <a:ea typeface="+mn-ea"/>
-                <a:cs typeface="+mn-cs"/>
-              </a:rPr>
-              <a:t> — verde, amarelo ou vermelho — e a expectativa de aprovação em</a:t>
-            </a:r>
-          </a:p>
-          <a:p>
-            <a:r>
-              <a:rPr lang="pt-BR" sz="1200" b="0" kern="1200" dirty="0">
-                <a:solidFill>
-                  <a:schemeClr val="tx1"/>
-                </a:solidFill>
-                <a:effectLst/>
-                <a:latin typeface="+mn-lt"/>
-                <a:ea typeface="+mn-ea"/>
-                <a:cs typeface="+mn-cs"/>
-              </a:rPr>
-              <a:t>quantas das quatro áreas.</a:t>
-            </a:r>
-          </a:p>
-          <a:p>
-            <a:r>
-              <a:rPr lang="pt-BR" sz="1200" b="0" i="1" kern="1200" dirty="0">
-                <a:solidFill>
-                  <a:schemeClr val="tx1"/>
-                </a:solidFill>
-                <a:effectLst/>
-                <a:latin typeface="+mn-lt"/>
-                <a:ea typeface="+mn-ea"/>
-                <a:cs typeface="+mn-cs"/>
-              </a:rPr>
-              <a:t>*(Demonstrar dois casos:)*</a:t>
-            </a:r>
-            <a:endParaRPr lang="pt-BR" sz="1200" b="0" kern="1200" dirty="0">
-              <a:solidFill>
-                <a:schemeClr val="tx1"/>
-              </a:solidFill>
-              <a:effectLst/>
-              <a:latin typeface="+mn-lt"/>
-              <a:ea typeface="+mn-ea"/>
-              <a:cs typeface="+mn-cs"/>
-            </a:endParaRPr>
-          </a:p>
-          <a:p>
-            <a:r>
-              <a:rPr lang="pt-BR" sz="1200" b="0" kern="1200" dirty="0">
-                <a:solidFill>
-                  <a:schemeClr val="tx1"/>
-                </a:solidFill>
-                <a:effectLst/>
-                <a:latin typeface="+mn-lt"/>
-                <a:ea typeface="+mn-ea"/>
-                <a:cs typeface="+mn-cs"/>
-              </a:rPr>
-              <a:t>Repare neste perfil de </a:t>
-            </a:r>
-            <a:r>
-              <a:rPr lang="pt-BR" sz="1200" b="1" kern="1200" dirty="0">
-                <a:solidFill>
-                  <a:schemeClr val="tx1"/>
-                </a:solidFill>
-                <a:effectLst/>
-                <a:latin typeface="+mn-lt"/>
-                <a:ea typeface="+mn-ea"/>
-                <a:cs typeface="+mn-cs"/>
-              </a:rPr>
-              <a:t>**alto risco**</a:t>
-            </a:r>
-            <a:r>
-              <a:rPr lang="pt-BR" sz="1200" b="0" kern="1200" dirty="0">
-                <a:solidFill>
-                  <a:schemeClr val="tx1"/>
-                </a:solidFill>
-                <a:effectLst/>
-                <a:latin typeface="+mn-lt"/>
-                <a:ea typeface="+mn-ea"/>
-                <a:cs typeface="+mn-cs"/>
-              </a:rPr>
-              <a:t>: candidato jovem, do Fundamental, baixa escolaridade —</a:t>
-            </a:r>
-          </a:p>
-          <a:p>
-            <a:r>
-              <a:rPr lang="pt-BR" sz="1200" b="0" kern="1200" dirty="0">
-                <a:solidFill>
-                  <a:schemeClr val="tx1"/>
-                </a:solidFill>
-                <a:effectLst/>
-                <a:latin typeface="+mn-lt"/>
-                <a:ea typeface="+mn-ea"/>
-                <a:cs typeface="+mn-cs"/>
-              </a:rPr>
-              <a:t>os vizinhos têm taxa de aprovação de só 37%. Agora um perfil de </a:t>
-            </a:r>
-            <a:r>
-              <a:rPr lang="pt-BR" sz="1200" b="1" kern="1200" dirty="0">
-                <a:solidFill>
-                  <a:schemeClr val="tx1"/>
-                </a:solidFill>
-                <a:effectLst/>
-                <a:latin typeface="+mn-lt"/>
-                <a:ea typeface="+mn-ea"/>
-                <a:cs typeface="+mn-cs"/>
-              </a:rPr>
-              <a:t>**baixo risco**</a:t>
-            </a:r>
-            <a:r>
-              <a:rPr lang="pt-BR" sz="1200" b="0" kern="1200" dirty="0">
-                <a:solidFill>
-                  <a:schemeClr val="tx1"/>
-                </a:solidFill>
-                <a:effectLst/>
-                <a:latin typeface="+mn-lt"/>
-                <a:ea typeface="+mn-ea"/>
-                <a:cs typeface="+mn-cs"/>
-              </a:rPr>
-              <a:t>: mais velho,</a:t>
-            </a:r>
-          </a:p>
-          <a:p>
-            <a:r>
-              <a:rPr lang="pt-BR" sz="1200" b="0" kern="1200" dirty="0">
-                <a:solidFill>
-                  <a:schemeClr val="tx1"/>
-                </a:solidFill>
-                <a:effectLst/>
-                <a:latin typeface="+mn-lt"/>
-                <a:ea typeface="+mn-ea"/>
-                <a:cs typeface="+mn-cs"/>
-              </a:rPr>
-              <a:t>Ensino Médio, renda mais alta — 85% dos semelhantes aprovados. O sistema deixa claro quais</a:t>
-            </a:r>
-          </a:p>
-          <a:p>
-            <a:r>
-              <a:rPr lang="pt-BR" sz="1200" b="0" kern="1200" dirty="0">
-                <a:solidFill>
-                  <a:schemeClr val="tx1"/>
-                </a:solidFill>
-                <a:effectLst/>
-                <a:latin typeface="+mn-lt"/>
-                <a:ea typeface="+mn-ea"/>
-                <a:cs typeface="+mn-cs"/>
-              </a:rPr>
-              <a:t>disciplinas são mais críticas.</a:t>
-            </a:r>
-          </a:p>
-          <a:p>
             <a:endParaRPr lang="pt-BR" sz="1200" b="0" kern="1200" dirty="0">
               <a:solidFill>
                 <a:schemeClr val="tx1"/>
@@ -2459,214 +1342,6 @@
           <a:bodyPr/>
           <a:lstStyle/>
           <a:p>
-            <a:r>
-              <a:rPr lang="pt-BR" sz="1200" b="0" kern="1200" dirty="0">
-                <a:solidFill>
-                  <a:schemeClr val="tx1"/>
-                </a:solidFill>
-                <a:effectLst/>
-                <a:latin typeface="+mn-lt"/>
-                <a:ea typeface="+mn-ea"/>
-                <a:cs typeface="+mn-cs"/>
-              </a:rPr>
-              <a:t>Abaixo, o sistema gera </a:t>
-            </a:r>
-            <a:r>
-              <a:rPr lang="pt-BR" sz="1200" b="1" kern="1200" dirty="0">
-                <a:solidFill>
-                  <a:schemeClr val="tx1"/>
-                </a:solidFill>
-                <a:effectLst/>
-                <a:latin typeface="+mn-lt"/>
-                <a:ea typeface="+mn-ea"/>
-                <a:cs typeface="+mn-cs"/>
-              </a:rPr>
-              <a:t>**recomendações automáticas**</a:t>
-            </a:r>
-            <a:r>
-              <a:rPr lang="pt-BR" sz="1200" b="0" kern="1200" dirty="0">
-                <a:solidFill>
-                  <a:schemeClr val="tx1"/>
-                </a:solidFill>
-                <a:effectLst/>
-                <a:latin typeface="+mn-lt"/>
-                <a:ea typeface="+mn-ea"/>
-                <a:cs typeface="+mn-cs"/>
-              </a:rPr>
-              <a:t> ao gestor: por exemplo, indicar a</a:t>
-            </a:r>
-          </a:p>
-          <a:p>
-            <a:r>
-              <a:rPr lang="pt-BR" sz="1200" b="0" kern="1200" dirty="0">
-                <a:solidFill>
-                  <a:schemeClr val="tx1"/>
-                </a:solidFill>
-                <a:effectLst/>
-                <a:latin typeface="+mn-lt"/>
-                <a:ea typeface="+mn-ea"/>
-                <a:cs typeface="+mn-cs"/>
-              </a:rPr>
-              <a:t>disciplina de maior atenção, sugerir reforço intensivo e acompanhamento individual para</a:t>
-            </a:r>
-          </a:p>
-          <a:p>
-            <a:r>
-              <a:rPr lang="pt-BR" sz="1200" b="0" kern="1200" dirty="0">
-                <a:solidFill>
-                  <a:schemeClr val="tx1"/>
-                </a:solidFill>
-                <a:effectLst/>
-                <a:latin typeface="+mn-lt"/>
-                <a:ea typeface="+mn-ea"/>
-                <a:cs typeface="+mn-cs"/>
-              </a:rPr>
-              <a:t>alto risco, ou alertar para redação fraca.</a:t>
-            </a:r>
-          </a:p>
-          <a:p>
-            <a:r>
-              <a:rPr lang="pt-BR" sz="1200" b="0" kern="1200" dirty="0">
-                <a:solidFill>
-                  <a:schemeClr val="tx1"/>
-                </a:solidFill>
-                <a:effectLst/>
-                <a:latin typeface="+mn-lt"/>
-                <a:ea typeface="+mn-ea"/>
-                <a:cs typeface="+mn-cs"/>
-              </a:rPr>
-              <a:t>E essas previsões têm respaldo. Numa avaliação com separação treino/teste, o erro médio das</a:t>
-            </a:r>
-          </a:p>
-          <a:p>
-            <a:r>
-              <a:rPr lang="pt-BR" sz="1200" b="0" kern="1200" dirty="0">
-                <a:solidFill>
-                  <a:schemeClr val="tx1"/>
-                </a:solidFill>
-                <a:effectLst/>
-                <a:latin typeface="+mn-lt"/>
-                <a:ea typeface="+mn-ea"/>
-                <a:cs typeface="+mn-cs"/>
-              </a:rPr>
-              <a:t>notas ficou em torno de </a:t>
-            </a:r>
-            <a:r>
-              <a:rPr lang="pt-BR" sz="1200" b="1" kern="1200" dirty="0">
-                <a:solidFill>
-                  <a:schemeClr val="tx1"/>
-                </a:solidFill>
-                <a:effectLst/>
-                <a:latin typeface="+mn-lt"/>
-                <a:ea typeface="+mn-ea"/>
-                <a:cs typeface="+mn-cs"/>
-              </a:rPr>
-              <a:t>**12 pontos**</a:t>
-            </a:r>
-            <a:r>
-              <a:rPr lang="pt-BR" sz="1200" b="0" kern="1200" dirty="0">
-                <a:solidFill>
-                  <a:schemeClr val="tx1"/>
-                </a:solidFill>
-                <a:effectLst/>
-                <a:latin typeface="+mn-lt"/>
-                <a:ea typeface="+mn-ea"/>
-                <a:cs typeface="+mn-cs"/>
-              </a:rPr>
-              <a:t>, e a previsão de aprovação acertou cerca de </a:t>
-            </a:r>
-            <a:r>
-              <a:rPr lang="pt-BR" sz="1200" b="1" kern="1200" dirty="0">
-                <a:solidFill>
-                  <a:schemeClr val="tx1"/>
-                </a:solidFill>
-                <a:effectLst/>
-                <a:latin typeface="+mn-lt"/>
-                <a:ea typeface="+mn-ea"/>
-                <a:cs typeface="+mn-cs"/>
-              </a:rPr>
-              <a:t>**87%**</a:t>
-            </a:r>
-            <a:r>
-              <a:rPr lang="pt-BR" sz="1200" b="0" kern="1200" dirty="0">
-                <a:solidFill>
-                  <a:schemeClr val="tx1"/>
-                </a:solidFill>
-                <a:effectLst/>
-                <a:latin typeface="+mn-lt"/>
-                <a:ea typeface="+mn-ea"/>
-                <a:cs typeface="+mn-cs"/>
-              </a:rPr>
-              <a:t> dos</a:t>
-            </a:r>
-          </a:p>
-          <a:p>
-            <a:r>
-              <a:rPr lang="pt-BR" sz="1200" b="0" kern="1200" dirty="0">
-                <a:solidFill>
-                  <a:schemeClr val="tx1"/>
-                </a:solidFill>
-                <a:effectLst/>
-                <a:latin typeface="+mn-lt"/>
-                <a:ea typeface="+mn-ea"/>
-                <a:cs typeface="+mn-cs"/>
-              </a:rPr>
-              <a:t>casos — usando </a:t>
-            </a:r>
-            <a:r>
-              <a:rPr lang="pt-BR" sz="1200" b="1" kern="1200" dirty="0">
-                <a:solidFill>
-                  <a:schemeClr val="tx1"/>
-                </a:solidFill>
-                <a:effectLst/>
-                <a:latin typeface="+mn-lt"/>
-                <a:ea typeface="+mn-ea"/>
-                <a:cs typeface="+mn-cs"/>
-              </a:rPr>
-              <a:t>**apenas o perfil socioeconômico**</a:t>
-            </a:r>
-            <a:r>
-              <a:rPr lang="pt-BR" sz="1200" b="0" kern="1200" dirty="0">
-                <a:solidFill>
-                  <a:schemeClr val="tx1"/>
-                </a:solidFill>
-                <a:effectLst/>
-                <a:latin typeface="+mn-lt"/>
-                <a:ea typeface="+mn-ea"/>
-                <a:cs typeface="+mn-cs"/>
-              </a:rPr>
-              <a:t>, sem nenhum dado de desempenho. Esse é o</a:t>
-            </a:r>
-          </a:p>
-          <a:p>
-            <a:r>
-              <a:rPr lang="pt-BR" sz="1200" b="0" kern="1200" dirty="0">
-                <a:solidFill>
-                  <a:schemeClr val="tx1"/>
-                </a:solidFill>
-                <a:effectLst/>
-                <a:latin typeface="+mn-lt"/>
-                <a:ea typeface="+mn-ea"/>
-                <a:cs typeface="+mn-cs"/>
-              </a:rPr>
-              <a:t>ponto mais importante: o perfil socioeconômico, sozinho, já carrega sinal real sobre o</a:t>
-            </a:r>
-          </a:p>
-          <a:p>
-            <a:r>
-              <a:rPr lang="pt-BR" sz="1200" b="0" kern="1200" dirty="0">
-                <a:solidFill>
-                  <a:schemeClr val="tx1"/>
-                </a:solidFill>
-                <a:effectLst/>
-                <a:latin typeface="+mn-lt"/>
-                <a:ea typeface="+mn-ea"/>
-                <a:cs typeface="+mn-cs"/>
-              </a:rPr>
-              <a:t>resultado no exame, o que justifica usá-lo para apoiar a decisão logo na matrícula.</a:t>
-            </a:r>
-          </a:p>
-          <a:p>
             <a:endParaRPr lang="en-US" dirty="0"/>
           </a:p>
         </p:txBody>
@@ -2750,76 +1425,6 @@
         <p:txBody>
           <a:bodyPr/>
           <a:lstStyle/>
-          <a:p>
-            <a:r>
-              <a:rPr lang="pt-BR" sz="1200" b="0" kern="1200" dirty="0">
-                <a:solidFill>
-                  <a:schemeClr val="tx1"/>
-                </a:solidFill>
-                <a:effectLst/>
-                <a:latin typeface="+mn-lt"/>
-                <a:ea typeface="+mn-ea"/>
-                <a:cs typeface="+mn-cs"/>
-              </a:rPr>
-              <a:t>Em resumo: transformei os microdados do ENCCEJA num sistema que ajuda o gestor a antecipar</a:t>
-            </a:r>
-          </a:p>
-          <a:p>
-            <a:r>
-              <a:rPr lang="pt-BR" sz="1200" b="0" kern="1200" dirty="0">
-                <a:solidFill>
-                  <a:schemeClr val="tx1"/>
-                </a:solidFill>
-                <a:effectLst/>
-                <a:latin typeface="+mn-lt"/>
-                <a:ea typeface="+mn-ea"/>
-                <a:cs typeface="+mn-cs"/>
-              </a:rPr>
-              <a:t>o risco de cada aluno e a direcionar reforço e acompanhamento de forma fundamentada, em vez</a:t>
-            </a:r>
-          </a:p>
-          <a:p>
-            <a:r>
-              <a:rPr lang="pt-BR" sz="1200" b="0" kern="1200" dirty="0">
-                <a:solidFill>
-                  <a:schemeClr val="tx1"/>
-                </a:solidFill>
-                <a:effectLst/>
-                <a:latin typeface="+mn-lt"/>
-                <a:ea typeface="+mn-ea"/>
-                <a:cs typeface="+mn-cs"/>
-              </a:rPr>
-              <a:t>de no "achismo". As limitações principais são que a base contém só quem concluiu o exame, e</a:t>
-            </a:r>
-          </a:p>
-          <a:p>
-            <a:r>
-              <a:rPr lang="pt-BR" sz="1200" b="0" kern="1200" dirty="0">
-                <a:solidFill>
-                  <a:schemeClr val="tx1"/>
-                </a:solidFill>
-                <a:effectLst/>
-                <a:latin typeface="+mn-lt"/>
-                <a:ea typeface="+mn-ea"/>
-                <a:cs typeface="+mn-cs"/>
-              </a:rPr>
-              <a:t>que o perfil explica parte, não tudo, do desempenho. Ainda assim, como ferramenta de apoio à</a:t>
-            </a:r>
-          </a:p>
-          <a:p>
-            <a:r>
-              <a:rPr lang="pt-BR" sz="1200" b="0" kern="1200" dirty="0">
-                <a:solidFill>
-                  <a:schemeClr val="tx1"/>
-                </a:solidFill>
-                <a:effectLst/>
-                <a:latin typeface="+mn-lt"/>
-                <a:ea typeface="+mn-ea"/>
-                <a:cs typeface="+mn-cs"/>
-              </a:rPr>
-              <a:t>decisão, ele entrega exatamente o que o problema pedia. Obrigado.</a:t>
-            </a:r>
-          </a:p>
           <a:p>
             <a:endParaRPr lang="en-US" dirty="0"/>
           </a:p>

</xml_diff>